<commit_message>
Update presentation: add Live ED, Email Triage, remove emojis
- Slide 1: Remove emoji and WORK IN PROGRESS label
- Slide 4: Tech architecture now shows Gmail SMTP + Twilio notifications
- Slide 6: Add Live ED Waiting Room innovation, update HIPAA section for email
- Slide 7: Live Demo slide now features Live ED page instead of SMS Triage
- Slide 9: Updated roadmap with Drug Interaction Alerts
- Slide 10: Updated tech stack with Gmail + Twilio

Co-Authored-By: Claude Opus 4.6 <noreply@anthropic.com>
</commit_message>
<xml_diff>
--- a/presentation/TriageFlow_Presentation.pptx
+++ b/presentation/TriageFlow_Presentation.pptx
@@ -1695,6 +1695,10 @@
           </a:solidFill>
           <a:ln/>
         </p:spPr>
+        <p:txBody>
+          <a:bodyPr/>
+          <a:p/>
+        </p:txBody>
       </p:sp>
       <p:sp>
         <p:nvSpPr>
@@ -1715,6 +1719,10 @@
           </a:solidFill>
           <a:ln/>
         </p:spPr>
+        <p:txBody>
+          <a:bodyPr/>
+          <a:p/>
+        </p:txBody>
       </p:sp>
       <p:sp>
         <p:nvSpPr>
@@ -1746,7 +1754,7 @@
                   <a:srgbClr val="000000"/>
                 </a:solidFill>
               </a:rPr>
-              <a:t>🏥</a:t>
+              <a:t/>
             </a:r>
             <a:endParaRPr lang="en-US" sz="4000" dirty="0"/>
           </a:p>
@@ -1866,6 +1874,10 @@
           </a:solidFill>
           <a:ln/>
         </p:spPr>
+        <p:txBody>
+          <a:bodyPr/>
+          <a:p/>
+        </p:txBody>
       </p:sp>
       <p:sp>
         <p:nvSpPr>
@@ -1925,6 +1937,10 @@
           </a:solidFill>
           <a:ln/>
         </p:spPr>
+        <p:txBody>
+          <a:bodyPr/>
+          <a:p/>
+        </p:txBody>
       </p:sp>
       <p:sp>
         <p:nvSpPr>
@@ -2023,45 +2039,6 @@
       </p:sp>
       <p:sp>
         <p:nvSpPr>
-          <p:cNvPr id="12" name="Text 10"/>
-          <p:cNvSpPr/>
-          <p:nvPr/>
-        </p:nvSpPr>
-        <p:spPr>
-          <a:xfrm>
-            <a:off x="6858000" y="4114800"/>
-            <a:ext cx="1828800" cy="320040"/>
-          </a:xfrm>
-          <a:prstGeom prst="rect">
-            <a:avLst/>
-          </a:prstGeom>
-          <a:noFill/>
-          <a:ln/>
-        </p:spPr>
-        <p:txBody>
-          <a:bodyPr wrap="square" rtlCol="0" anchor="ctr"/>
-          <a:lstStyle/>
-          <a:p>
-            <a:pPr algn="ctr" indent="0" marL="0">
-              <a:buNone/>
-            </a:pPr>
-            <a:r>
-              <a:rPr lang="en-US" sz="900" b="1" dirty="0">
-                <a:solidFill>
-                  <a:srgbClr val="EF4444"/>
-                </a:solidFill>
-                <a:latin typeface="Calibri" pitchFamily="34" charset="0"/>
-                <a:ea typeface="Calibri" pitchFamily="34" charset="-122"/>
-                <a:cs typeface="Calibri" pitchFamily="34" charset="-120"/>
-              </a:rPr>
-              <a:t>WORK IN PROGRESS</a:t>
-            </a:r>
-            <a:endParaRPr lang="en-US" sz="900" dirty="0"/>
-          </a:p>
-        </p:txBody>
-      </p:sp>
-      <p:sp>
-        <p:nvSpPr>
           <p:cNvPr id="13" name="Shape 11"/>
           <p:cNvSpPr/>
           <p:nvPr/>
@@ -2079,6 +2056,10 @@
           </a:solidFill>
           <a:ln/>
         </p:spPr>
+        <p:txBody>
+          <a:bodyPr/>
+          <a:p/>
+        </p:txBody>
       </p:sp>
       <p:sp>
         <p:nvSpPr>
@@ -2159,6 +2140,10 @@
           </a:solidFill>
           <a:ln/>
         </p:spPr>
+        <p:txBody>
+          <a:bodyPr/>
+          <a:p/>
+        </p:txBody>
       </p:sp>
       <p:sp>
         <p:nvSpPr>
@@ -2190,7 +2175,7 @@
                   <a:srgbClr val="000000"/>
                 </a:solidFill>
               </a:rPr>
-              <a:t>🏥</a:t>
+              <a:t/>
             </a:r>
             <a:endParaRPr lang="en-US" sz="3600" dirty="0"/>
           </a:p>
@@ -2254,6 +2239,10 @@
           </a:solidFill>
           <a:ln/>
         </p:spPr>
+        <p:txBody>
+          <a:bodyPr/>
+          <a:p/>
+        </p:txBody>
       </p:sp>
       <p:sp>
         <p:nvSpPr>
@@ -2327,6 +2316,10 @@
           </a:solidFill>
           <a:ln/>
         </p:spPr>
+        <p:txBody>
+          <a:bodyPr/>
+          <a:p/>
+        </p:txBody>
       </p:sp>
       <p:sp>
         <p:nvSpPr>
@@ -2400,6 +2393,10 @@
           </a:solidFill>
           <a:ln/>
         </p:spPr>
+        <p:txBody>
+          <a:bodyPr/>
+          <a:p/>
+        </p:txBody>
       </p:sp>
       <p:sp>
         <p:nvSpPr>
@@ -2459,6 +2456,10 @@
           </a:solidFill>
           <a:ln/>
         </p:spPr>
+        <p:txBody>
+          <a:bodyPr/>
+          <a:p/>
+        </p:txBody>
       </p:sp>
       <p:sp>
         <p:nvSpPr>
@@ -2518,6 +2519,10 @@
           </a:solidFill>
           <a:ln/>
         </p:spPr>
+        <p:txBody>
+          <a:bodyPr/>
+          <a:p/>
+        </p:txBody>
       </p:sp>
       <p:sp>
         <p:nvSpPr>
@@ -2577,6 +2582,10 @@
           </a:solidFill>
           <a:ln/>
         </p:spPr>
+        <p:txBody>
+          <a:bodyPr/>
+          <a:p/>
+        </p:txBody>
       </p:sp>
       <p:sp>
         <p:nvSpPr>
@@ -2611,7 +2620,7 @@
                 <a:ea typeface="Calibri" pitchFamily="34" charset="-122"/>
                 <a:cs typeface="Calibri" pitchFamily="34" charset="-120"/>
               </a:rPr>
-              <a:t>Twilio</a:t>
+              <a:t>Gmail + Twilio</a:t>
             </a:r>
             <a:endParaRPr lang="en-US" sz="1000" dirty="0"/>
           </a:p>
@@ -2636,6 +2645,10 @@
           </a:solidFill>
           <a:ln/>
         </p:spPr>
+        <p:txBody>
+          <a:bodyPr/>
+          <a:p/>
+        </p:txBody>
       </p:sp>
       <p:sp>
         <p:nvSpPr>
@@ -2695,6 +2708,10 @@
           </a:solidFill>
           <a:ln/>
         </p:spPr>
+        <p:txBody>
+          <a:bodyPr/>
+          <a:p/>
+        </p:txBody>
       </p:sp>
       <p:sp>
         <p:nvSpPr>
@@ -2793,6 +2810,10 @@
           </a:solidFill>
           <a:ln/>
         </p:spPr>
+        <p:txBody>
+          <a:bodyPr/>
+          <a:p/>
+        </p:txBody>
       </p:sp>
       <p:sp>
         <p:nvSpPr>
@@ -4496,6 +4517,10 @@
           </a:solidFill>
           <a:ln/>
         </p:spPr>
+        <p:txBody>
+          <a:bodyPr/>
+          <a:p/>
+        </p:txBody>
       </p:sp>
       <p:sp>
         <p:nvSpPr>
@@ -4562,6 +4587,10 @@
             </a:outerShdw>
           </a:effectLst>
         </p:spPr>
+        <p:txBody>
+          <a:bodyPr/>
+          <a:p/>
+        </p:txBody>
       </p:sp>
       <p:sp>
         <p:nvSpPr>
@@ -4582,6 +4611,10 @@
           </a:solidFill>
           <a:ln/>
         </p:spPr>
+        <p:txBody>
+          <a:bodyPr/>
+          <a:p/>
+        </p:txBody>
       </p:sp>
       <p:sp>
         <p:nvSpPr>
@@ -4613,7 +4646,7 @@
                   <a:srgbClr val="000000"/>
                 </a:solidFill>
               </a:rPr>
-              <a:t>🖥️</a:t>
+              <a:t/>
             </a:r>
             <a:endParaRPr lang="en-US" sz="2200" dirty="0"/>
           </a:p>
@@ -4740,6 +4773,10 @@
             </a:outerShdw>
           </a:effectLst>
         </p:spPr>
+        <p:txBody>
+          <a:bodyPr/>
+          <a:p/>
+        </p:txBody>
       </p:sp>
       <p:sp>
         <p:nvSpPr>
@@ -4760,6 +4797,10 @@
           </a:solidFill>
           <a:ln/>
         </p:spPr>
+        <p:txBody>
+          <a:bodyPr/>
+          <a:p/>
+        </p:txBody>
       </p:sp>
       <p:sp>
         <p:nvSpPr>
@@ -4791,7 +4832,7 @@
                   <a:srgbClr val="000000"/>
                 </a:solidFill>
               </a:rPr>
-              <a:t>🤖</a:t>
+              <a:t/>
             </a:r>
             <a:endParaRPr lang="en-US" sz="2200" dirty="0"/>
           </a:p>
@@ -4918,6 +4959,10 @@
             </a:outerShdw>
           </a:effectLst>
         </p:spPr>
+        <p:txBody>
+          <a:bodyPr/>
+          <a:p/>
+        </p:txBody>
       </p:sp>
       <p:sp>
         <p:nvSpPr>
@@ -4938,6 +4983,10 @@
           </a:solidFill>
           <a:ln/>
         </p:spPr>
+        <p:txBody>
+          <a:bodyPr/>
+          <a:p/>
+        </p:txBody>
       </p:sp>
       <p:sp>
         <p:nvSpPr>
@@ -4969,7 +5018,7 @@
                   <a:srgbClr val="000000"/>
                 </a:solidFill>
               </a:rPr>
-              <a:t>🧠</a:t>
+              <a:t/>
             </a:r>
             <a:endParaRPr lang="en-US" sz="2200" dirty="0"/>
           </a:p>
@@ -5096,6 +5145,10 @@
             </a:outerShdw>
           </a:effectLst>
         </p:spPr>
+        <p:txBody>
+          <a:bodyPr/>
+          <a:p/>
+        </p:txBody>
       </p:sp>
       <p:sp>
         <p:nvSpPr>
@@ -5116,6 +5169,10 @@
           </a:solidFill>
           <a:ln/>
         </p:spPr>
+        <p:txBody>
+          <a:bodyPr/>
+          <a:p/>
+        </p:txBody>
       </p:sp>
       <p:sp>
         <p:nvSpPr>
@@ -5147,7 +5204,7 @@
                   <a:srgbClr val="000000"/>
                 </a:solidFill>
               </a:rPr>
-              <a:t>🗄️</a:t>
+              <a:t/>
             </a:r>
             <a:endParaRPr lang="en-US" sz="2200" dirty="0"/>
           </a:p>
@@ -5274,6 +5331,10 @@
             </a:outerShdw>
           </a:effectLst>
         </p:spPr>
+        <p:txBody>
+          <a:bodyPr/>
+          <a:p/>
+        </p:txBody>
       </p:sp>
       <p:sp>
         <p:nvSpPr>
@@ -5294,6 +5355,10 @@
           </a:solidFill>
           <a:ln/>
         </p:spPr>
+        <p:txBody>
+          <a:bodyPr/>
+          <a:p/>
+        </p:txBody>
       </p:sp>
       <p:sp>
         <p:nvSpPr>
@@ -5325,7 +5390,7 @@
                   <a:srgbClr val="000000"/>
                 </a:solidFill>
               </a:rPr>
-              <a:t>📱</a:t>
+              <a:t/>
             </a:r>
             <a:endParaRPr lang="en-US" sz="2200" dirty="0"/>
           </a:p>
@@ -5364,7 +5429,7 @@
                 <a:ea typeface="Calibri" pitchFamily="34" charset="-122"/>
                 <a:cs typeface="Calibri" pitchFamily="34" charset="-120"/>
               </a:rPr>
-              <a:t>SMS</a:t>
+              <a:t>Notifications</a:t>
             </a:r>
             <a:endParaRPr lang="en-US" sz="1500" dirty="0"/>
           </a:p>
@@ -5403,7 +5468,7 @@
                 <a:ea typeface="Calibri" pitchFamily="34" charset="-122"/>
                 <a:cs typeface="Calibri" pitchFamily="34" charset="-120"/>
               </a:rPr>
-              <a:t>Twilio API</a:t>
+              <a:t>Gmail SMTP + Twilio</a:t>
             </a:r>
             <a:endParaRPr lang="en-US" sz="1100" dirty="0"/>
           </a:p>
@@ -5420,7 +5485,7 @@
                 <a:ea typeface="Calibri" pitchFamily="34" charset="-122"/>
                 <a:cs typeface="Calibri" pitchFamily="34" charset="-120"/>
               </a:rPr>
-              <a:t>Mock + Live, HIPAA-aware</a:t>
+              <a:t>Email &amp; SMS, HIPAA-aware</a:t>
             </a:r>
             <a:endParaRPr lang="en-US" sz="1100" dirty="0"/>
           </a:p>
@@ -5452,6 +5517,10 @@
             </a:outerShdw>
           </a:effectLst>
         </p:spPr>
+        <p:txBody>
+          <a:bodyPr/>
+          <a:p/>
+        </p:txBody>
       </p:sp>
       <p:sp>
         <p:nvSpPr>
@@ -5472,6 +5541,10 @@
           </a:solidFill>
           <a:ln/>
         </p:spPr>
+        <p:txBody>
+          <a:bodyPr/>
+          <a:p/>
+        </p:txBody>
       </p:sp>
       <p:sp>
         <p:nvSpPr>
@@ -5503,7 +5576,7 @@
                   <a:srgbClr val="000000"/>
                 </a:solidFill>
               </a:rPr>
-              <a:t>☁️</a:t>
+              <a:t/>
             </a:r>
             <a:endParaRPr lang="en-US" sz="2200" dirty="0"/>
           </a:p>
@@ -5623,6 +5696,10 @@
           </a:solidFill>
           <a:ln/>
         </p:spPr>
+        <p:txBody>
+          <a:bodyPr/>
+          <a:p/>
+        </p:txBody>
       </p:sp>
       <p:sp>
         <p:nvSpPr>
@@ -7246,6 +7323,10 @@
           </a:solidFill>
           <a:ln/>
         </p:spPr>
+        <p:txBody>
+          <a:bodyPr/>
+          <a:p/>
+        </p:txBody>
       </p:sp>
       <p:sp>
         <p:nvSpPr>
@@ -7312,6 +7393,10 @@
             </a:outerShdw>
           </a:effectLst>
         </p:spPr>
+        <p:txBody>
+          <a:bodyPr/>
+          <a:p/>
+        </p:txBody>
       </p:sp>
       <p:sp>
         <p:nvSpPr>
@@ -7332,6 +7417,10 @@
           </a:solidFill>
           <a:ln/>
         </p:spPr>
+        <p:txBody>
+          <a:bodyPr/>
+          <a:p/>
+        </p:txBody>
       </p:sp>
       <p:sp>
         <p:nvSpPr>
@@ -7352,6 +7441,10 @@
           </a:solidFill>
           <a:ln/>
         </p:spPr>
+        <p:txBody>
+          <a:bodyPr/>
+          <a:p/>
+        </p:txBody>
       </p:sp>
       <p:sp>
         <p:nvSpPr>
@@ -7457,6 +7550,10 @@
             </a:outerShdw>
           </a:effectLst>
         </p:spPr>
+        <p:txBody>
+          <a:bodyPr/>
+          <a:p/>
+        </p:txBody>
       </p:sp>
       <p:sp>
         <p:nvSpPr>
@@ -7477,6 +7574,10 @@
           </a:solidFill>
           <a:ln/>
         </p:spPr>
+        <p:txBody>
+          <a:bodyPr/>
+          <a:p/>
+        </p:txBody>
       </p:sp>
       <p:sp>
         <p:nvSpPr>
@@ -7497,6 +7598,10 @@
           </a:solidFill>
           <a:ln/>
         </p:spPr>
+        <p:txBody>
+          <a:bodyPr/>
+          <a:p/>
+        </p:txBody>
       </p:sp>
       <p:sp>
         <p:nvSpPr>
@@ -7531,7 +7636,7 @@
                 <a:ea typeface="Calibri" pitchFamily="34" charset="-122"/>
                 <a:cs typeface="Calibri" pitchFamily="34" charset="-120"/>
               </a:rPr>
-              <a:t>HIPAA-Compliant SMS</a:t>
+              <a:t>HIPAA-Compliant Notifications</a:t>
             </a:r>
             <a:endParaRPr lang="en-US" sz="1600" dirty="0"/>
           </a:p>
@@ -7570,7 +7675,7 @@
                 <a:ea typeface="Calibri" pitchFamily="34" charset="-122"/>
                 <a:cs typeface="Calibri" pitchFamily="34" charset="-120"/>
               </a:rPr>
-              <a:t>BC HSP validation, no PHI in SMS body, SHA-256 hashed audit trail, masked phone numbers.</a:t>
+              <a:t>Email + SMS triage. No PHI in message body, SHA-256 hashed audit trail, Gmail SMTP with TLS.</a:t>
             </a:r>
             <a:endParaRPr lang="en-US" sz="1200" dirty="0"/>
           </a:p>
@@ -7602,6 +7707,10 @@
             </a:outerShdw>
           </a:effectLst>
         </p:spPr>
+        <p:txBody>
+          <a:bodyPr/>
+          <a:p/>
+        </p:txBody>
       </p:sp>
       <p:sp>
         <p:nvSpPr>
@@ -7622,6 +7731,10 @@
           </a:solidFill>
           <a:ln/>
         </p:spPr>
+        <p:txBody>
+          <a:bodyPr/>
+          <a:p/>
+        </p:txBody>
       </p:sp>
       <p:sp>
         <p:nvSpPr>
@@ -7642,6 +7755,10 @@
           </a:solidFill>
           <a:ln/>
         </p:spPr>
+        <p:txBody>
+          <a:bodyPr/>
+          <a:p/>
+        </p:txBody>
       </p:sp>
       <p:sp>
         <p:nvSpPr>
@@ -7747,6 +7864,10 @@
             </a:outerShdw>
           </a:effectLst>
         </p:spPr>
+        <p:txBody>
+          <a:bodyPr/>
+          <a:p/>
+        </p:txBody>
       </p:sp>
       <p:sp>
         <p:nvSpPr>
@@ -7767,6 +7888,10 @@
           </a:solidFill>
           <a:ln/>
         </p:spPr>
+        <p:txBody>
+          <a:bodyPr/>
+          <a:p/>
+        </p:txBody>
       </p:sp>
       <p:sp>
         <p:nvSpPr>
@@ -7787,6 +7912,10 @@
           </a:solidFill>
           <a:ln/>
         </p:spPr>
+        <p:txBody>
+          <a:bodyPr/>
+          <a:p/>
+        </p:txBody>
       </p:sp>
       <p:sp>
         <p:nvSpPr>
@@ -7821,7 +7950,7 @@
                 <a:ea typeface="Calibri" pitchFamily="34" charset="-122"/>
                 <a:cs typeface="Calibri" pitchFamily="34" charset="-120"/>
               </a:rPr>
-              <a:t>Drug Interaction Checking</a:t>
+              <a:t>Live ED Waiting Room</a:t>
             </a:r>
             <a:endParaRPr lang="en-US" sz="1600" dirty="0"/>
           </a:p>
@@ -7860,7 +7989,7 @@
                 <a:ea typeface="Calibri" pitchFamily="34" charset="-122"/>
                 <a:cs typeface="Calibri" pitchFamily="34" charset="-120"/>
               </a:rPr>
-              <a:t>Cross-references active medications. AI-generated plain-language explanations of severity and risk.</a:t>
+              <a:t>Audience joins a simulated ED queue. Real ML triage determines position. Queue simulates live with auto email notification when the doctor is ready.</a:t>
             </a:r>
             <a:endParaRPr lang="en-US" sz="1200" dirty="0"/>
           </a:p>
@@ -7885,6 +8014,10 @@
           </a:solidFill>
           <a:ln/>
         </p:spPr>
+        <p:txBody>
+          <a:bodyPr/>
+          <a:p/>
+        </p:txBody>
       </p:sp>
       <p:sp>
         <p:nvSpPr>
@@ -8015,6 +8148,10 @@
           </a:solidFill>
           <a:ln/>
         </p:spPr>
+        <p:txBody>
+          <a:bodyPr/>
+          <a:p/>
+        </p:txBody>
       </p:sp>
       <p:sp>
         <p:nvSpPr>
@@ -8129,6 +8266,10 @@
             </a:outerShdw>
           </a:effectLst>
         </p:spPr>
+        <p:txBody>
+          <a:bodyPr/>
+          <a:p/>
+        </p:txBody>
       </p:sp>
       <p:sp>
         <p:nvSpPr>
@@ -8149,6 +8290,10 @@
           </a:solidFill>
           <a:ln/>
         </p:spPr>
+        <p:txBody>
+          <a:bodyPr/>
+          <a:p/>
+        </p:txBody>
       </p:sp>
       <p:sp>
         <p:nvSpPr>
@@ -8180,7 +8325,7 @@
                   <a:srgbClr val="000000"/>
                 </a:solidFill>
               </a:rPr>
-              <a:t>🧭</a:t>
+              <a:t/>
             </a:r>
             <a:endParaRPr lang="en-US" sz="2800" dirty="0"/>
           </a:p>
@@ -8324,6 +8469,10 @@
             </a:outerShdw>
           </a:effectLst>
         </p:spPr>
+        <p:txBody>
+          <a:bodyPr/>
+          <a:p/>
+        </p:txBody>
       </p:sp>
       <p:sp>
         <p:nvSpPr>
@@ -8344,6 +8493,10 @@
           </a:solidFill>
           <a:ln/>
         </p:spPr>
+        <p:txBody>
+          <a:bodyPr/>
+          <a:p/>
+        </p:txBody>
       </p:sp>
       <p:sp>
         <p:nvSpPr>
@@ -8375,7 +8528,7 @@
                   <a:srgbClr val="000000"/>
                 </a:solidFill>
               </a:rPr>
-              <a:t>📊</a:t>
+              <a:t/>
             </a:r>
             <a:endParaRPr lang="en-US" sz="2800" dirty="0"/>
           </a:p>
@@ -8519,6 +8672,10 @@
             </a:outerShdw>
           </a:effectLst>
         </p:spPr>
+        <p:txBody>
+          <a:bodyPr/>
+          <a:p/>
+        </p:txBody>
       </p:sp>
       <p:sp>
         <p:nvSpPr>
@@ -8539,6 +8696,10 @@
           </a:solidFill>
           <a:ln/>
         </p:spPr>
+        <p:txBody>
+          <a:bodyPr/>
+          <a:p/>
+        </p:txBody>
       </p:sp>
       <p:sp>
         <p:nvSpPr>
@@ -8570,7 +8731,7 @@
                   <a:srgbClr val="000000"/>
                 </a:solidFill>
               </a:rPr>
-              <a:t>📱</a:t>
+              <a:t/>
             </a:r>
             <a:endParaRPr lang="en-US" sz="2800" dirty="0"/>
           </a:p>
@@ -8609,7 +8770,7 @@
                 <a:ea typeface="Calibri" pitchFamily="34" charset="-122"/>
                 <a:cs typeface="Calibri" pitchFamily="34" charset="-120"/>
               </a:rPr>
-              <a:t>SMS Triage</a:t>
+              <a:t>Live ED</a:t>
             </a:r>
             <a:endParaRPr lang="en-US" sz="1400" dirty="0"/>
           </a:p>
@@ -8648,7 +8809,7 @@
                 <a:ea typeface="Calibri" pitchFamily="34" charset="-122"/>
                 <a:cs typeface="Calibri" pitchFamily="34" charset="-120"/>
               </a:rPr>
-              <a:t>Phone mockup preview</a:t>
+              <a:t>Join the queue live</a:t>
             </a:r>
             <a:endParaRPr lang="en-US" sz="1100" dirty="0"/>
           </a:p>
@@ -8665,7 +8826,7 @@
                 <a:ea typeface="Calibri" pitchFamily="34" charset="-122"/>
                 <a:cs typeface="Calibri" pitchFamily="34" charset="-120"/>
               </a:rPr>
-              <a:t>HIPAA audit log</a:t>
+              <a:t>Real ML triage</a:t>
             </a:r>
             <a:endParaRPr lang="en-US" sz="1100" dirty="0"/>
           </a:p>
@@ -8682,7 +8843,7 @@
                 <a:ea typeface="Calibri" pitchFamily="34" charset="-122"/>
                 <a:cs typeface="Calibri" pitchFamily="34" charset="-120"/>
               </a:rPr>
-              <a:t>BC HSP validation</a:t>
+              <a:t>Email notification</a:t>
             </a:r>
             <a:endParaRPr lang="en-US" sz="1100" dirty="0"/>
           </a:p>
@@ -8714,6 +8875,10 @@
             </a:outerShdw>
           </a:effectLst>
         </p:spPr>
+        <p:txBody>
+          <a:bodyPr/>
+          <a:p/>
+        </p:txBody>
       </p:sp>
       <p:sp>
         <p:nvSpPr>
@@ -8734,6 +8899,10 @@
           </a:solidFill>
           <a:ln/>
         </p:spPr>
+        <p:txBody>
+          <a:bodyPr/>
+          <a:p/>
+        </p:txBody>
       </p:sp>
       <p:sp>
         <p:nvSpPr>
@@ -8765,7 +8934,7 @@
                   <a:srgbClr val="000000"/>
                 </a:solidFill>
               </a:rPr>
-              <a:t>⚡</a:t>
+              <a:t/>
             </a:r>
             <a:endParaRPr lang="en-US" sz="2800" dirty="0"/>
           </a:p>
@@ -8902,6 +9071,10 @@
           </a:solidFill>
           <a:ln/>
         </p:spPr>
+        <p:txBody>
+          <a:bodyPr/>
+          <a:p/>
+        </p:txBody>
       </p:sp>
       <p:sp>
         <p:nvSpPr>
@@ -9947,6 +10120,10 @@
           </a:solidFill>
           <a:ln/>
         </p:spPr>
+        <p:txBody>
+          <a:bodyPr/>
+          <a:p/>
+        </p:txBody>
       </p:sp>
       <p:sp>
         <p:nvSpPr>
@@ -10013,6 +10190,10 @@
             </a:outerShdw>
           </a:effectLst>
         </p:spPr>
+        <p:txBody>
+          <a:bodyPr/>
+          <a:p/>
+        </p:txBody>
       </p:sp>
       <p:sp>
         <p:nvSpPr>
@@ -10033,6 +10214,10 @@
           </a:solidFill>
           <a:ln/>
         </p:spPr>
+        <p:txBody>
+          <a:bodyPr/>
+          <a:p/>
+        </p:txBody>
       </p:sp>
       <p:sp>
         <p:nvSpPr>
@@ -10064,7 +10249,7 @@
                   <a:srgbClr val="000000"/>
                 </a:solidFill>
               </a:rPr>
-              <a:t>🔗</a:t>
+              <a:t/>
             </a:r>
             <a:endParaRPr lang="en-US" sz="2200" dirty="0"/>
           </a:p>
@@ -10174,6 +10359,10 @@
             </a:outerShdw>
           </a:effectLst>
         </p:spPr>
+        <p:txBody>
+          <a:bodyPr/>
+          <a:p/>
+        </p:txBody>
       </p:sp>
       <p:sp>
         <p:nvSpPr>
@@ -10194,6 +10383,10 @@
           </a:solidFill>
           <a:ln/>
         </p:spPr>
+        <p:txBody>
+          <a:bodyPr/>
+          <a:p/>
+        </p:txBody>
       </p:sp>
       <p:sp>
         <p:nvSpPr>
@@ -10225,7 +10418,7 @@
                   <a:srgbClr val="000000"/>
                 </a:solidFill>
               </a:rPr>
-              <a:t>📱</a:t>
+              <a:t/>
             </a:r>
             <a:endParaRPr lang="en-US" sz="2200" dirty="0"/>
           </a:p>
@@ -10264,7 +10457,7 @@
                 <a:ea typeface="Calibri" pitchFamily="34" charset="-122"/>
                 <a:cs typeface="Calibri" pitchFamily="34" charset="-120"/>
               </a:rPr>
-              <a:t>Live SMS with Consent</a:t>
+              <a:t>Drug Interaction Alerts</a:t>
             </a:r>
             <a:endParaRPr lang="en-US" sz="1500" dirty="0"/>
           </a:p>
@@ -10303,7 +10496,7 @@
                 <a:ea typeface="Calibri" pitchFamily="34" charset="-122"/>
                 <a:cs typeface="Calibri" pitchFamily="34" charset="-120"/>
               </a:rPr>
-              <a:t>Production Twilio integration with patient consent workflow and opt-in/opt-out</a:t>
+              <a:t>Real-time drug interaction alerts via email when new medications are prescribed</a:t>
             </a:r>
             <a:endParaRPr lang="en-US" sz="1200" dirty="0"/>
           </a:p>
@@ -10335,6 +10528,10 @@
             </a:outerShdw>
           </a:effectLst>
         </p:spPr>
+        <p:txBody>
+          <a:bodyPr/>
+          <a:p/>
+        </p:txBody>
       </p:sp>
       <p:sp>
         <p:nvSpPr>
@@ -10355,6 +10552,10 @@
           </a:solidFill>
           <a:ln/>
         </p:spPr>
+        <p:txBody>
+          <a:bodyPr/>
+          <a:p/>
+        </p:txBody>
       </p:sp>
       <p:sp>
         <p:nvSpPr>
@@ -10386,7 +10587,7 @@
                   <a:srgbClr val="000000"/>
                 </a:solidFill>
               </a:rPr>
-              <a:t>🌍</a:t>
+              <a:t/>
             </a:r>
             <a:endParaRPr lang="en-US" sz="2200" dirty="0"/>
           </a:p>
@@ -10496,6 +10697,10 @@
             </a:outerShdw>
           </a:effectLst>
         </p:spPr>
+        <p:txBody>
+          <a:bodyPr/>
+          <a:p/>
+        </p:txBody>
       </p:sp>
       <p:sp>
         <p:nvSpPr>
@@ -10516,6 +10721,10 @@
           </a:solidFill>
           <a:ln/>
         </p:spPr>
+        <p:txBody>
+          <a:bodyPr/>
+          <a:p/>
+        </p:txBody>
       </p:sp>
       <p:sp>
         <p:nvSpPr>
@@ -10547,7 +10756,7 @@
                   <a:srgbClr val="000000"/>
                 </a:solidFill>
               </a:rPr>
-              <a:t>🏥</a:t>
+              <a:t/>
             </a:r>
             <a:endParaRPr lang="en-US" sz="2200" dirty="0"/>
           </a:p>
@@ -10650,6 +10859,10 @@
           </a:solidFill>
           <a:ln/>
         </p:spPr>
+        <p:txBody>
+          <a:bodyPr/>
+          <a:p/>
+        </p:txBody>
       </p:sp>
       <p:sp>
         <p:nvSpPr>

</xml_diff>

<commit_message>
Add QR code linking to triageflow.streamlit.app on title and closing slides
Co-Authored-By: Claude Opus 4.6 <noreply@anthropic.com>
</commit_message>
<xml_diff>
--- a/presentation/TriageFlow_Presentation.pptx
+++ b/presentation/TriageFlow_Presentation.pptx
@@ -2089,6 +2089,30 @@
           </a:p>
         </p:txBody>
       </p:sp>
+      <p:pic>
+        <p:nvPicPr>
+          <p:cNvPr id="15" name="Picture 14" descr="qr_code.png"/>
+          <p:cNvPicPr>
+            <a:picLocks noChangeAspect="1"/>
+          </p:cNvPicPr>
+          <p:nvPr/>
+        </p:nvPicPr>
+        <p:blipFill>
+          <a:blip r:embed="rId3"/>
+          <a:stretch>
+            <a:fillRect/>
+          </a:stretch>
+        </p:blipFill>
+        <p:spPr>
+          <a:xfrm>
+            <a:off x="7132320" y="3657600"/>
+            <a:ext cx="1463040" cy="1463040"/>
+          </a:xfrm>
+          <a:prstGeom prst="rect">
+            <a:avLst/>
+          </a:prstGeom>
+        </p:spPr>
+      </p:pic>
     </p:spTree>
   </p:cSld>
   <p:clrMapOvr>
@@ -2843,6 +2867,30 @@
           </a:p>
         </p:txBody>
       </p:sp>
+      <p:pic>
+        <p:nvPicPr>
+          <p:cNvPr id="24" name="Picture 23" descr="qr_code.png"/>
+          <p:cNvPicPr>
+            <a:picLocks noChangeAspect="1"/>
+          </p:cNvPicPr>
+          <p:nvPr/>
+        </p:nvPicPr>
+        <p:blipFill>
+          <a:blip r:embed="rId3"/>
+          <a:stretch>
+            <a:fillRect/>
+          </a:stretch>
+        </p:blipFill>
+        <p:spPr>
+          <a:xfrm>
+            <a:off x="6858000" y="2011680"/>
+            <a:ext cx="1828800" cy="1828800"/>
+          </a:xfrm>
+          <a:prstGeom prst="rect">
+            <a:avLst/>
+          </a:prstGeom>
+        </p:spPr>
+      </p:pic>
     </p:spTree>
   </p:cSld>
   <p:clrMapOvr>

</xml_diff>